<commit_message>
fixed issues regarding presentation formatting in the eda tools and skills
</commit_message>
<xml_diff>
--- a/outputs/EDA/Full_Data_executive_summary.pptx
+++ b/outputs/EDA/Full_Data_executive_summary.pptx
@@ -5,20 +5,20 @@
     <p:sldMasterId id="2147483648" r:id="rId4"/>
   </p:sldMasterIdLst>
   <p:notesMasterIdLst>
-    <p:notesMasterId r:id="rId16"/>
+    <p:notesMasterId r:id="rId8"/>
   </p:notesMasterIdLst>
   <p:sldIdLst>
-    <p:sldId id="256" r:id="rId5"/>
+    <p:sldId id="256" r:id="rId7"/>
     <p:sldId id="257" r:id="rId6"/>
-    <p:sldId id="258" r:id="rId7"/>
-    <p:sldId id="259" r:id="rId8"/>
-    <p:sldId id="260" r:id="rId9"/>
-    <p:sldId id="261" r:id="rId10"/>
-    <p:sldId id="262" r:id="rId11"/>
-    <p:sldId id="263" r:id="rId12"/>
-    <p:sldId id="264" r:id="rId13"/>
-    <p:sldId id="265" r:id="rId14"/>
-    <p:sldId id="266" r:id="rId15"/>
+    <p:sldId id="258" r:id="rId5"/>
+    <p:sldId id="259" r:id="rId14"/>
+    <p:sldId id="260" r:id="rId15"/>
+    <p:sldId id="261" r:id="rId16"/>
+    <p:sldId id="262" r:id="rId17"/>
+    <p:sldId id="263" r:id="rId18"/>
+    <p:sldId id="264" r:id="rId19"/>
+    <p:sldId id="265" r:id="rId20"/>
+    <p:sldId id="266" r:id="rId21"/>
   </p:sldIdLst>
   <p:sldSz cx="9144000" cy="5143500" type="screen16x9"/>
   <p:notesSz cx="5143500" cy="9144000"/>
@@ -568,7 +568,7 @@
 </file>
 
 <file path=ppt/slides/slide1.xml><?xml version="1.0" encoding="utf-8"?>
-<p:sld xmlns:a="http://schemas.openxmlformats.org/drawingml/2006/main" xmlns:r="http://schemas.openxmlformats.org/officeDocument/2006/relationships" xmlns:p="http://schemas.openxmlformats.org/presentationml/2006/main">
+<p:sld xmlns:a="http://schemas.openxmlformats.org/drawingml/2006/main" xmlns:p="http://schemas.openxmlformats.org/presentationml/2006/main" xmlns:r="http://schemas.openxmlformats.org/officeDocument/2006/relationships">
   <p:cSld>
     <p:bg>
       <p:bgPr>
@@ -584,14 +584,7 @@
         <p:cNvGrpSpPr/>
         <p:nvPr/>
       </p:nvGrpSpPr>
-      <p:grpSpPr>
-        <a:xfrm>
-          <a:off x="0" y="0"/>
-          <a:ext cx="0" cy="0"/>
-          <a:chOff x="0" y="0"/>
-          <a:chExt cx="0" cy="0"/>
-        </a:xfrm>
-      </p:grpSpPr>
+      <p:grpSpPr/>
       <p:sp>
         <p:nvSpPr>
           <p:cNvPr id="2" name="TextBox 1"/>
@@ -609,8 +602,8 @@
           <a:noFill/>
         </p:spPr>
         <p:txBody>
-          <a:bodyPr wrap="square">
-            <a:spAutoFit/>
+          <a:bodyPr wrap="square" tIns="54864" bIns="54864">
+            <a:normAutofit/>
           </a:bodyPr>
           <a:lstStyle/>
           <a:p>
@@ -652,8 +645,8 @@
           <a:noFill/>
         </p:spPr>
         <p:txBody>
-          <a:bodyPr wrap="square">
-            <a:spAutoFit/>
+          <a:bodyPr wrap="square" tIns="54864" bIns="54864">
+            <a:normAutofit/>
           </a:bodyPr>
           <a:lstStyle/>
           <a:p>
@@ -685,8 +678,8 @@
           <a:noFill/>
         </p:spPr>
         <p:txBody>
-          <a:bodyPr wrap="square">
-            <a:spAutoFit/>
+          <a:bodyPr wrap="square" tIns="54864" bIns="54864">
+            <a:normAutofit/>
           </a:bodyPr>
           <a:lstStyle/>
           <a:p>
@@ -775,7 +768,7 @@
 </file>
 
 <file path=ppt/slides/slide10.xml><?xml version="1.0" encoding="utf-8"?>
-<p:sld xmlns:a="http://schemas.openxmlformats.org/drawingml/2006/main" xmlns:r="http://schemas.openxmlformats.org/officeDocument/2006/relationships" xmlns:p="http://schemas.openxmlformats.org/presentationml/2006/main">
+<p:sld xmlns:a="http://schemas.openxmlformats.org/drawingml/2006/main" xmlns:p="http://schemas.openxmlformats.org/presentationml/2006/main" xmlns:r="http://schemas.openxmlformats.org/officeDocument/2006/relationships">
   <p:cSld>
     <p:spTree>
       <p:nvGrpSpPr>
@@ -783,14 +776,7 @@
         <p:cNvGrpSpPr/>
         <p:nvPr/>
       </p:nvGrpSpPr>
-      <p:grpSpPr>
-        <a:xfrm>
-          <a:off x="0" y="0"/>
-          <a:ext cx="0" cy="0"/>
-          <a:chOff x="0" y="0"/>
-          <a:chExt cx="0" cy="0"/>
-        </a:xfrm>
-      </p:grpSpPr>
+      <p:grpSpPr/>
       <p:sp>
         <p:nvSpPr>
           <p:cNvPr id="2" name="TextBox 1"/>
@@ -799,7 +785,7 @@
         </p:nvSpPr>
         <p:spPr>
           <a:xfrm>
-            <a:off x="411480" y="182880"/>
+            <a:off x="411480" y="201168"/>
             <a:ext cx="8321040" cy="274320"/>
           </a:xfrm>
           <a:prstGeom prst="rect">
@@ -808,8 +794,8 @@
           <a:noFill/>
         </p:spPr>
         <p:txBody>
-          <a:bodyPr wrap="square">
-            <a:spAutoFit/>
+          <a:bodyPr wrap="square" tIns="54864" bIns="54864">
+            <a:normAutofit/>
           </a:bodyPr>
           <a:lstStyle/>
           <a:p>
@@ -832,7 +818,7 @@
         </p:nvSpPr>
         <p:spPr>
           <a:xfrm>
-            <a:off x="411480" y="457200"/>
+            <a:off x="411480" y="493775"/>
             <a:ext cx="8321040" cy="548640"/>
           </a:xfrm>
           <a:prstGeom prst="rect">
@@ -841,8 +827,8 @@
           <a:noFill/>
         </p:spPr>
         <p:txBody>
-          <a:bodyPr wrap="square">
-            <a:spAutoFit/>
+          <a:bodyPr wrap="square" tIns="54864" bIns="54864">
+            <a:normAutofit/>
           </a:bodyPr>
           <a:lstStyle/>
           <a:p>
@@ -865,7 +851,7 @@
         </p:nvSpPr>
         <p:spPr>
           <a:xfrm>
-            <a:off x="411480" y="1024128"/>
+            <a:off x="411480" y="1133855"/>
             <a:ext cx="8321040" cy="18000"/>
           </a:xfrm>
           <a:prstGeom prst="rect">
@@ -897,7 +883,6 @@
           <a:lstStyle/>
           <a:p>
             <a:pPr algn="ctr"/>
-            <a:endParaRPr/>
           </a:p>
         </p:txBody>
       </p:sp>
@@ -909,8 +894,8 @@
         </p:nvSpPr>
         <p:spPr>
           <a:xfrm>
-            <a:off x="502920" y="1115568"/>
-            <a:ext cx="8229600" cy="3657600"/>
+            <a:off x="502920" y="1271015"/>
+            <a:ext cx="8229600" cy="3474720"/>
           </a:xfrm>
           <a:prstGeom prst="rect">
             <a:avLst/>
@@ -918,13 +903,11 @@
           <a:noFill/>
         </p:spPr>
         <p:txBody>
-          <a:bodyPr wrap="square">
-            <a:spAutoFit/>
+          <a:bodyPr wrap="square" tIns="54864" bIns="54864">
+            <a:normAutofit/>
           </a:bodyPr>
           <a:lstStyle/>
-          <a:p>
-            <a:endParaRPr/>
-          </a:p>
+          <a:p/>
           <a:p>
             <a:pPr>
               <a:spcAft>
@@ -1041,7 +1024,7 @@
 </file>
 
 <file path=ppt/slides/slide11.xml><?xml version="1.0" encoding="utf-8"?>
-<p:sld xmlns:a="http://schemas.openxmlformats.org/drawingml/2006/main" xmlns:r="http://schemas.openxmlformats.org/officeDocument/2006/relationships" xmlns:p="http://schemas.openxmlformats.org/presentationml/2006/main">
+<p:sld xmlns:a="http://schemas.openxmlformats.org/drawingml/2006/main" xmlns:p="http://schemas.openxmlformats.org/presentationml/2006/main" xmlns:r="http://schemas.openxmlformats.org/officeDocument/2006/relationships">
   <p:cSld>
     <p:bg>
       <p:bgPr>
@@ -1057,14 +1040,7 @@
         <p:cNvGrpSpPr/>
         <p:nvPr/>
       </p:nvGrpSpPr>
-      <p:grpSpPr>
-        <a:xfrm>
-          <a:off x="0" y="0"/>
-          <a:ext cx="0" cy="0"/>
-          <a:chOff x="0" y="0"/>
-          <a:chExt cx="0" cy="0"/>
-        </a:xfrm>
-      </p:grpSpPr>
+      <p:grpSpPr/>
       <p:sp>
         <p:nvSpPr>
           <p:cNvPr id="2" name="TextBox 1"/>
@@ -1082,8 +1058,8 @@
           <a:noFill/>
         </p:spPr>
         <p:txBody>
-          <a:bodyPr wrap="square">
-            <a:spAutoFit/>
+          <a:bodyPr wrap="square" tIns="54864" bIns="54864">
+            <a:normAutofit/>
           </a:bodyPr>
           <a:lstStyle/>
           <a:p>
@@ -1115,8 +1091,8 @@
           <a:noFill/>
         </p:spPr>
         <p:txBody>
-          <a:bodyPr wrap="square">
-            <a:spAutoFit/>
+          <a:bodyPr wrap="square" tIns="54864" bIns="54864">
+            <a:normAutofit/>
           </a:bodyPr>
           <a:lstStyle/>
           <a:p>
@@ -1230,8 +1206,8 @@
           <a:noFill/>
         </p:spPr>
         <p:txBody>
-          <a:bodyPr wrap="square">
-            <a:spAutoFit/>
+          <a:bodyPr wrap="square" tIns="54864" bIns="54864">
+            <a:normAutofit/>
           </a:bodyPr>
           <a:lstStyle/>
           <a:p>
@@ -1256,7 +1232,7 @@
 </file>
 
 <file path=ppt/slides/slide2.xml><?xml version="1.0" encoding="utf-8"?>
-<p:sld xmlns:a="http://schemas.openxmlformats.org/drawingml/2006/main" xmlns:r="http://schemas.openxmlformats.org/officeDocument/2006/relationships" xmlns:p="http://schemas.openxmlformats.org/presentationml/2006/main">
+<p:sld xmlns:a="http://schemas.openxmlformats.org/drawingml/2006/main" xmlns:p="http://schemas.openxmlformats.org/presentationml/2006/main" xmlns:r="http://schemas.openxmlformats.org/officeDocument/2006/relationships">
   <p:cSld>
     <p:spTree>
       <p:nvGrpSpPr>
@@ -1264,14 +1240,7 @@
         <p:cNvGrpSpPr/>
         <p:nvPr/>
       </p:nvGrpSpPr>
-      <p:grpSpPr>
-        <a:xfrm>
-          <a:off x="0" y="0"/>
-          <a:ext cx="0" cy="0"/>
-          <a:chOff x="0" y="0"/>
-          <a:chExt cx="0" cy="0"/>
-        </a:xfrm>
-      </p:grpSpPr>
+      <p:grpSpPr/>
       <p:sp>
         <p:nvSpPr>
           <p:cNvPr id="2" name="TextBox 1"/>
@@ -1280,7 +1249,7 @@
         </p:nvSpPr>
         <p:spPr>
           <a:xfrm>
-            <a:off x="411480" y="182880"/>
+            <a:off x="411480" y="201168"/>
             <a:ext cx="8321040" cy="274320"/>
           </a:xfrm>
           <a:prstGeom prst="rect">
@@ -1289,8 +1258,8 @@
           <a:noFill/>
         </p:spPr>
         <p:txBody>
-          <a:bodyPr wrap="square">
-            <a:spAutoFit/>
+          <a:bodyPr wrap="square" tIns="54864" bIns="54864">
+            <a:normAutofit/>
           </a:bodyPr>
           <a:lstStyle/>
           <a:p>
@@ -1313,7 +1282,7 @@
         </p:nvSpPr>
         <p:spPr>
           <a:xfrm>
-            <a:off x="411480" y="457200"/>
+            <a:off x="411480" y="493775"/>
             <a:ext cx="8321040" cy="548640"/>
           </a:xfrm>
           <a:prstGeom prst="rect">
@@ -1322,8 +1291,8 @@
           <a:noFill/>
         </p:spPr>
         <p:txBody>
-          <a:bodyPr wrap="square">
-            <a:spAutoFit/>
+          <a:bodyPr wrap="square" tIns="54864" bIns="54864">
+            <a:normAutofit/>
           </a:bodyPr>
           <a:lstStyle/>
           <a:p>
@@ -1333,7 +1302,7 @@
                   <a:srgbClr val="1F2D50"/>
                 </a:solidFill>
               </a:rPr>
-              <a:t>One row = one mailed prospect in a Capital One credit-card campaign</a:t>
+              <a:t>One row = one mailed prospect in the campaign</a:t>
             </a:r>
           </a:p>
         </p:txBody>
@@ -1346,7 +1315,7 @@
         </p:nvSpPr>
         <p:spPr>
           <a:xfrm>
-            <a:off x="411480" y="1024128"/>
+            <a:off x="411480" y="1133855"/>
             <a:ext cx="8321040" cy="18000"/>
           </a:xfrm>
           <a:prstGeom prst="rect">
@@ -1378,7 +1347,6 @@
           <a:lstStyle/>
           <a:p>
             <a:pPr algn="ctr"/>
-            <a:endParaRPr/>
           </a:p>
         </p:txBody>
       </p:sp>
@@ -1390,8 +1358,8 @@
         </p:nvSpPr>
         <p:spPr>
           <a:xfrm>
-            <a:off x="502920" y="1115568"/>
-            <a:ext cx="8229600" cy="2286000"/>
+            <a:off x="502920" y="1271015"/>
+            <a:ext cx="8229600" cy="2103120"/>
           </a:xfrm>
           <a:prstGeom prst="rect">
             <a:avLst/>
@@ -1399,13 +1367,11 @@
           <a:noFill/>
         </p:spPr>
         <p:txBody>
-          <a:bodyPr wrap="square">
-            <a:spAutoFit/>
+          <a:bodyPr wrap="square" tIns="54864" bIns="54864">
+            <a:normAutofit/>
           </a:bodyPr>
           <a:lstStyle/>
-          <a:p>
-            <a:endParaRPr/>
-          </a:p>
+          <a:p/>
           <a:p>
             <a:pPr>
               <a:spcAft>
@@ -1491,7 +1457,7 @@
         </p:nvSpPr>
         <p:spPr>
           <a:xfrm>
-            <a:off x="411480" y="3566160"/>
+            <a:off x="411480" y="3511295"/>
             <a:ext cx="1645920" cy="1188720"/>
           </a:xfrm>
           <a:prstGeom prst="rect">
@@ -1521,7 +1487,7 @@
           </a:fontRef>
         </p:style>
         <p:txBody>
-          <a:bodyPr wrap="square" rtlCol="0" anchor="ctr"/>
+          <a:bodyPr rtlCol="0" anchor="ctr" wrap="square"/>
           <a:lstStyle/>
           <a:p>
             <a:pPr algn="ctr"/>
@@ -1555,7 +1521,7 @@
         </p:nvSpPr>
         <p:spPr>
           <a:xfrm>
-            <a:off x="2148840" y="3566160"/>
+            <a:off x="2148840" y="3511295"/>
             <a:ext cx="1645920" cy="1188720"/>
           </a:xfrm>
           <a:prstGeom prst="rect">
@@ -1585,7 +1551,7 @@
           </a:fontRef>
         </p:style>
         <p:txBody>
-          <a:bodyPr wrap="square" rtlCol="0" anchor="ctr"/>
+          <a:bodyPr rtlCol="0" anchor="ctr" wrap="square"/>
           <a:lstStyle/>
           <a:p>
             <a:pPr algn="ctr"/>
@@ -1619,7 +1585,7 @@
         </p:nvSpPr>
         <p:spPr>
           <a:xfrm>
-            <a:off x="3886200" y="3566160"/>
+            <a:off x="3886200" y="3511295"/>
             <a:ext cx="1645920" cy="1188720"/>
           </a:xfrm>
           <a:prstGeom prst="rect">
@@ -1649,7 +1615,7 @@
           </a:fontRef>
         </p:style>
         <p:txBody>
-          <a:bodyPr wrap="square" rtlCol="0" anchor="ctr"/>
+          <a:bodyPr rtlCol="0" anchor="ctr" wrap="square"/>
           <a:lstStyle/>
           <a:p>
             <a:pPr algn="ctr"/>
@@ -1683,7 +1649,7 @@
         </p:nvSpPr>
         <p:spPr>
           <a:xfrm>
-            <a:off x="5623560" y="3566160"/>
+            <a:off x="5623560" y="3511295"/>
             <a:ext cx="1645920" cy="1188720"/>
           </a:xfrm>
           <a:prstGeom prst="rect">
@@ -1713,7 +1679,7 @@
           </a:fontRef>
         </p:style>
         <p:txBody>
-          <a:bodyPr wrap="square" rtlCol="0" anchor="ctr"/>
+          <a:bodyPr rtlCol="0" anchor="ctr" wrap="square"/>
           <a:lstStyle/>
           <a:p>
             <a:pPr algn="ctr"/>
@@ -1747,7 +1713,7 @@
         </p:nvSpPr>
         <p:spPr>
           <a:xfrm>
-            <a:off x="7360920" y="3566160"/>
+            <a:off x="7360920" y="3511295"/>
             <a:ext cx="1645920" cy="1188720"/>
           </a:xfrm>
           <a:prstGeom prst="rect">
@@ -1777,7 +1743,7 @@
           </a:fontRef>
         </p:style>
         <p:txBody>
-          <a:bodyPr wrap="square" rtlCol="0" anchor="ctr"/>
+          <a:bodyPr rtlCol="0" anchor="ctr" wrap="square"/>
           <a:lstStyle/>
           <a:p>
             <a:pPr algn="ctr"/>
@@ -1812,7 +1778,7 @@
 </file>
 
 <file path=ppt/slides/slide3.xml><?xml version="1.0" encoding="utf-8"?>
-<p:sld xmlns:a="http://schemas.openxmlformats.org/drawingml/2006/main" xmlns:r="http://schemas.openxmlformats.org/officeDocument/2006/relationships" xmlns:p="http://schemas.openxmlformats.org/presentationml/2006/main">
+<p:sld xmlns:a="http://schemas.openxmlformats.org/drawingml/2006/main" xmlns:p="http://schemas.openxmlformats.org/presentationml/2006/main" xmlns:r="http://schemas.openxmlformats.org/officeDocument/2006/relationships">
   <p:cSld>
     <p:spTree>
       <p:nvGrpSpPr>
@@ -1820,14 +1786,7 @@
         <p:cNvGrpSpPr/>
         <p:nvPr/>
       </p:nvGrpSpPr>
-      <p:grpSpPr>
-        <a:xfrm>
-          <a:off x="0" y="0"/>
-          <a:ext cx="0" cy="0"/>
-          <a:chOff x="0" y="0"/>
-          <a:chExt cx="0" cy="0"/>
-        </a:xfrm>
-      </p:grpSpPr>
+      <p:grpSpPr/>
       <p:sp>
         <p:nvSpPr>
           <p:cNvPr id="2" name="TextBox 1"/>
@@ -1836,7 +1795,7 @@
         </p:nvSpPr>
         <p:spPr>
           <a:xfrm>
-            <a:off x="411480" y="182880"/>
+            <a:off x="411480" y="201168"/>
             <a:ext cx="8321040" cy="274320"/>
           </a:xfrm>
           <a:prstGeom prst="rect">
@@ -1845,8 +1804,8 @@
           <a:noFill/>
         </p:spPr>
         <p:txBody>
-          <a:bodyPr wrap="square">
-            <a:spAutoFit/>
+          <a:bodyPr wrap="square" tIns="54864" bIns="54864">
+            <a:normAutofit/>
           </a:bodyPr>
           <a:lstStyle/>
           <a:p>
@@ -1869,7 +1828,7 @@
         </p:nvSpPr>
         <p:spPr>
           <a:xfrm>
-            <a:off x="411480" y="457200"/>
+            <a:off x="411480" y="493775"/>
             <a:ext cx="8321040" cy="548640"/>
           </a:xfrm>
           <a:prstGeom prst="rect">
@@ -1878,8 +1837,8 @@
           <a:noFill/>
         </p:spPr>
         <p:txBody>
-          <a:bodyPr wrap="square">
-            <a:spAutoFit/>
+          <a:bodyPr wrap="square" tIns="54864" bIns="54864">
+            <a:normAutofit/>
           </a:bodyPr>
           <a:lstStyle/>
           <a:p>
@@ -1889,7 +1848,7 @@
                   <a:srgbClr val="1F2D50"/>
                 </a:solidFill>
               </a:rPr>
-              <a:t>The file is structurally sound — but hidden 'missing by design' values needed correcting</a:t>
+              <a:t>Clean file — hidden sentinel codes needed correcting</a:t>
             </a:r>
           </a:p>
         </p:txBody>
@@ -1902,7 +1861,7 @@
         </p:nvSpPr>
         <p:spPr>
           <a:xfrm>
-            <a:off x="411480" y="1024128"/>
+            <a:off x="411480" y="1133855"/>
             <a:ext cx="8321040" cy="18000"/>
           </a:xfrm>
           <a:prstGeom prst="rect">
@@ -1934,7 +1893,6 @@
           <a:lstStyle/>
           <a:p>
             <a:pPr algn="ctr"/>
-            <a:endParaRPr/>
           </a:p>
         </p:txBody>
       </p:sp>
@@ -1946,8 +1904,8 @@
         </p:nvSpPr>
         <p:spPr>
           <a:xfrm>
-            <a:off x="502920" y="1115568"/>
-            <a:ext cx="8229600" cy="1371600"/>
+            <a:off x="502920" y="1271015"/>
+            <a:ext cx="8229600" cy="1005840"/>
           </a:xfrm>
           <a:prstGeom prst="rect">
             <a:avLst/>
@@ -1955,13 +1913,11 @@
           <a:noFill/>
         </p:spPr>
         <p:txBody>
-          <a:bodyPr wrap="square">
-            <a:spAutoFit/>
+          <a:bodyPr wrap="square" tIns="54864" bIns="54864">
+            <a:normAutofit/>
           </a:bodyPr>
           <a:lstStyle/>
-          <a:p>
-            <a:endParaRPr/>
-          </a:p>
+          <a:p/>
           <a:p>
             <a:pPr>
               <a:spcAft>
@@ -2017,7 +1973,7 @@
         </p:nvSpPr>
         <p:spPr>
           <a:xfrm>
-            <a:off x="411480" y="2578608"/>
+            <a:off x="411480" y="2414015"/>
             <a:ext cx="8321040" cy="18000"/>
           </a:xfrm>
           <a:prstGeom prst="rect">
@@ -2049,7 +2005,6 @@
           <a:lstStyle/>
           <a:p>
             <a:pPr algn="ctr"/>
-            <a:endParaRPr/>
           </a:p>
         </p:txBody>
       </p:sp>
@@ -2061,7 +2016,7 @@
         </p:nvSpPr>
         <p:spPr>
           <a:xfrm>
-            <a:off x="502920" y="2697480"/>
+            <a:off x="502920" y="2551175"/>
             <a:ext cx="8229600" cy="1737360"/>
           </a:xfrm>
           <a:prstGeom prst="rect">
@@ -2070,13 +2025,11 @@
           <a:noFill/>
         </p:spPr>
         <p:txBody>
-          <a:bodyPr wrap="square">
-            <a:spAutoFit/>
+          <a:bodyPr wrap="square" tIns="54864" bIns="54864">
+            <a:normAutofit/>
           </a:bodyPr>
           <a:lstStyle/>
-          <a:p>
-            <a:endParaRPr/>
-          </a:p>
+          <a:p/>
           <a:p>
             <a:pPr>
               <a:spcAft>
@@ -2148,7 +2101,7 @@
 </file>
 
 <file path=ppt/slides/slide4.xml><?xml version="1.0" encoding="utf-8"?>
-<p:sld xmlns:a="http://schemas.openxmlformats.org/drawingml/2006/main" xmlns:r="http://schemas.openxmlformats.org/officeDocument/2006/relationships" xmlns:p="http://schemas.openxmlformats.org/presentationml/2006/main">
+<p:sld xmlns:a="http://schemas.openxmlformats.org/drawingml/2006/main" xmlns:p="http://schemas.openxmlformats.org/presentationml/2006/main" xmlns:r="http://schemas.openxmlformats.org/officeDocument/2006/relationships">
   <p:cSld>
     <p:spTree>
       <p:nvGrpSpPr>
@@ -2156,14 +2109,7 @@
         <p:cNvGrpSpPr/>
         <p:nvPr/>
       </p:nvGrpSpPr>
-      <p:grpSpPr>
-        <a:xfrm>
-          <a:off x="0" y="0"/>
-          <a:ext cx="0" cy="0"/>
-          <a:chOff x="0" y="0"/>
-          <a:chExt cx="0" cy="0"/>
-        </a:xfrm>
-      </p:grpSpPr>
+      <p:grpSpPr/>
       <p:sp>
         <p:nvSpPr>
           <p:cNvPr id="2" name="TextBox 1"/>
@@ -2172,7 +2118,7 @@
         </p:nvSpPr>
         <p:spPr>
           <a:xfrm>
-            <a:off x="411480" y="182880"/>
+            <a:off x="411480" y="201168"/>
             <a:ext cx="8321040" cy="274320"/>
           </a:xfrm>
           <a:prstGeom prst="rect">
@@ -2181,8 +2127,8 @@
           <a:noFill/>
         </p:spPr>
         <p:txBody>
-          <a:bodyPr wrap="square">
-            <a:spAutoFit/>
+          <a:bodyPr wrap="square" tIns="54864" bIns="54864">
+            <a:normAutofit/>
           </a:bodyPr>
           <a:lstStyle/>
           <a:p>
@@ -2205,7 +2151,7 @@
         </p:nvSpPr>
         <p:spPr>
           <a:xfrm>
-            <a:off x="411480" y="457200"/>
+            <a:off x="411480" y="493775"/>
             <a:ext cx="8321040" cy="548640"/>
           </a:xfrm>
           <a:prstGeom prst="rect">
@@ -2214,8 +2160,8 @@
           <a:noFill/>
         </p:spPr>
         <p:txBody>
-          <a:bodyPr wrap="square">
-            <a:spAutoFit/>
+          <a:bodyPr wrap="square" tIns="54864" bIns="54864">
+            <a:normAutofit/>
           </a:bodyPr>
           <a:lstStyle/>
           <a:p>
@@ -2225,7 +2171,7 @@
                   <a:srgbClr val="1F2D50"/>
                 </a:solidFill>
               </a:rPr>
-              <a:t>Three bureaus report the same fields — effectively triple-counting the signal</a:t>
+              <a:t>Three bureaus, one signal — largely redundant data</a:t>
             </a:r>
           </a:p>
         </p:txBody>
@@ -2238,7 +2184,7 @@
         </p:nvSpPr>
         <p:spPr>
           <a:xfrm>
-            <a:off x="411480" y="1024128"/>
+            <a:off x="411480" y="1133855"/>
             <a:ext cx="8321040" cy="18000"/>
           </a:xfrm>
           <a:prstGeom prst="rect">
@@ -2270,7 +2216,6 @@
           <a:lstStyle/>
           <a:p>
             <a:pPr algn="ctr"/>
-            <a:endParaRPr/>
           </a:p>
         </p:txBody>
       </p:sp>
@@ -2282,8 +2227,8 @@
         </p:nvSpPr>
         <p:spPr>
           <a:xfrm>
-            <a:off x="411480" y="1399587"/>
-            <a:ext cx="4214099" cy="2631490"/>
+            <a:off x="411480" y="1271015"/>
+            <a:ext cx="4206240" cy="3017520"/>
           </a:xfrm>
           <a:prstGeom prst="rect">
             <a:avLst/>
@@ -2291,13 +2236,11 @@
           <a:noFill/>
         </p:spPr>
         <p:txBody>
-          <a:bodyPr wrap="square">
-            <a:spAutoFit/>
+          <a:bodyPr wrap="square" tIns="54864" bIns="54864">
+            <a:normAutofit/>
           </a:bodyPr>
           <a:lstStyle/>
-          <a:p>
-            <a:endParaRPr dirty="0"/>
-          </a:p>
+          <a:p/>
           <a:p>
             <a:pPr>
               <a:spcAft>
@@ -2305,7 +2248,7 @@
               </a:spcAft>
             </a:pPr>
             <a:r>
-              <a:rPr sz="1200" b="0" dirty="0">
+              <a:rPr sz="1200" b="0">
                 <a:solidFill>
                   <a:srgbClr val="333333"/>
                 </a:solidFill>
@@ -2320,7 +2263,7 @@
               </a:spcAft>
             </a:pPr>
             <a:r>
-              <a:rPr sz="1200" b="1" dirty="0">
+              <a:rPr sz="1200" b="1">
                 <a:solidFill>
                   <a:srgbClr val="2E8B57"/>
                 </a:solidFill>
@@ -2335,7 +2278,7 @@
               </a:spcAft>
             </a:pPr>
             <a:r>
-              <a:rPr sz="1200" b="1" dirty="0">
+              <a:rPr sz="1200" b="1">
                 <a:solidFill>
                   <a:srgbClr val="C88A00"/>
                 </a:solidFill>
@@ -2350,7 +2293,7 @@
               </a:spcAft>
             </a:pPr>
             <a:r>
-              <a:rPr sz="1200" b="0" dirty="0">
+              <a:rPr sz="1200" b="0">
                 <a:solidFill>
                   <a:srgbClr val="333333"/>
                 </a:solidFill>
@@ -2376,8 +2319,8 @@
         </p:blipFill>
         <p:spPr>
           <a:xfrm>
-            <a:off x="4625579" y="1115569"/>
-            <a:ext cx="4248257" cy="2583596"/>
+            <a:off x="4754880" y="1271015"/>
+            <a:ext cx="4069080" cy="2325188"/>
           </a:xfrm>
           <a:prstGeom prst="rect">
             <a:avLst/>
@@ -2392,8 +2335,8 @@
         </p:nvSpPr>
         <p:spPr>
           <a:xfrm>
-            <a:off x="411480" y="4526280"/>
-            <a:ext cx="8321040" cy="320040"/>
+            <a:off x="4754880" y="3733364"/>
+            <a:ext cx="4069080" cy="320040"/>
           </a:xfrm>
           <a:prstGeom prst="rect">
             <a:avLst/>
@@ -2401,8 +2344,8 @@
           <a:noFill/>
         </p:spPr>
         <p:txBody>
-          <a:bodyPr wrap="square">
-            <a:spAutoFit/>
+          <a:bodyPr wrap="square" tIns="54864" bIns="54864">
+            <a:normAutofit/>
           </a:bodyPr>
           <a:lstStyle/>
           <a:p>
@@ -2427,7 +2370,7 @@
 </file>
 
 <file path=ppt/slides/slide5.xml><?xml version="1.0" encoding="utf-8"?>
-<p:sld xmlns:a="http://schemas.openxmlformats.org/drawingml/2006/main" xmlns:r="http://schemas.openxmlformats.org/officeDocument/2006/relationships" xmlns:p="http://schemas.openxmlformats.org/presentationml/2006/main">
+<p:sld xmlns:a="http://schemas.openxmlformats.org/drawingml/2006/main" xmlns:p="http://schemas.openxmlformats.org/presentationml/2006/main" xmlns:r="http://schemas.openxmlformats.org/officeDocument/2006/relationships">
   <p:cSld>
     <p:spTree>
       <p:nvGrpSpPr>
@@ -2435,14 +2378,7 @@
         <p:cNvGrpSpPr/>
         <p:nvPr/>
       </p:nvGrpSpPr>
-      <p:grpSpPr>
-        <a:xfrm>
-          <a:off x="0" y="0"/>
-          <a:ext cx="0" cy="0"/>
-          <a:chOff x="0" y="0"/>
-          <a:chExt cx="0" cy="0"/>
-        </a:xfrm>
-      </p:grpSpPr>
+      <p:grpSpPr/>
       <p:sp>
         <p:nvSpPr>
           <p:cNvPr id="2" name="TextBox 1"/>
@@ -2451,7 +2387,7 @@
         </p:nvSpPr>
         <p:spPr>
           <a:xfrm>
-            <a:off x="411480" y="182880"/>
+            <a:off x="411480" y="201168"/>
             <a:ext cx="8321040" cy="274320"/>
           </a:xfrm>
           <a:prstGeom prst="rect">
@@ -2460,8 +2396,8 @@
           <a:noFill/>
         </p:spPr>
         <p:txBody>
-          <a:bodyPr wrap="square">
-            <a:spAutoFit/>
+          <a:bodyPr wrap="square" tIns="54864" bIns="54864">
+            <a:normAutofit/>
           </a:bodyPr>
           <a:lstStyle/>
           <a:p>
@@ -2484,7 +2420,7 @@
         </p:nvSpPr>
         <p:spPr>
           <a:xfrm>
-            <a:off x="411480" y="457200"/>
+            <a:off x="411480" y="493775"/>
             <a:ext cx="8321040" cy="548640"/>
           </a:xfrm>
           <a:prstGeom prst="rect">
@@ -2493,8 +2429,8 @@
           <a:noFill/>
         </p:spPr>
         <p:txBody>
-          <a:bodyPr wrap="square">
-            <a:spAutoFit/>
+          <a:bodyPr wrap="square" tIns="54864" bIns="54864">
+            <a:normAutofit/>
           </a:bodyPr>
           <a:lstStyle/>
           <a:p>
@@ -2504,7 +2440,7 @@
                   <a:srgbClr val="1F2D50"/>
                 </a:solidFill>
               </a:rPr>
-              <a:t>Credit scores are normally distributed; balances and income have a long right tail</a:t>
+              <a:t>Credit scores are normal; balances and income skew right</a:t>
             </a:r>
           </a:p>
         </p:txBody>
@@ -2517,7 +2453,7 @@
         </p:nvSpPr>
         <p:spPr>
           <a:xfrm>
-            <a:off x="411480" y="1024128"/>
+            <a:off x="411480" y="1133855"/>
             <a:ext cx="8321040" cy="18000"/>
           </a:xfrm>
           <a:prstGeom prst="rect">
@@ -2549,7 +2485,6 @@
           <a:lstStyle/>
           <a:p>
             <a:pPr algn="ctr"/>
-            <a:endParaRPr/>
           </a:p>
         </p:txBody>
       </p:sp>
@@ -2569,8 +2504,8 @@
         </p:blipFill>
         <p:spPr>
           <a:xfrm>
-            <a:off x="4457700" y="1179000"/>
-            <a:ext cx="4579158" cy="2789208"/>
+            <a:off x="2923539" y="1271015"/>
+            <a:ext cx="3251200" cy="1828800"/>
           </a:xfrm>
           <a:prstGeom prst="rect">
             <a:avLst/>
@@ -2585,7 +2520,7 @@
         </p:nvSpPr>
         <p:spPr>
           <a:xfrm>
-            <a:off x="2275378" y="4030542"/>
+            <a:off x="411480" y="3236975"/>
             <a:ext cx="8321040" cy="320040"/>
           </a:xfrm>
           <a:prstGeom prst="rect">
@@ -2594,14 +2529,14 @@
           <a:noFill/>
         </p:spPr>
         <p:txBody>
-          <a:bodyPr wrap="square">
-            <a:spAutoFit/>
+          <a:bodyPr wrap="square" tIns="54864" bIns="54864">
+            <a:normAutofit/>
           </a:bodyPr>
           <a:lstStyle/>
           <a:p>
             <a:pPr algn="ctr"/>
             <a:r>
-              <a:rPr sz="1000" i="1" dirty="0">
+              <a:rPr sz="1000" i="1">
                 <a:solidFill>
                   <a:srgbClr val="555555"/>
                 </a:solidFill>
@@ -2619,8 +2554,8 @@
         </p:nvSpPr>
         <p:spPr>
           <a:xfrm>
-            <a:off x="249171" y="1478027"/>
-            <a:ext cx="3807229" cy="2000548"/>
+            <a:off x="411480" y="3694176"/>
+            <a:ext cx="8321040" cy="914400"/>
           </a:xfrm>
           <a:prstGeom prst="rect">
             <a:avLst/>
@@ -2628,13 +2563,11 @@
           <a:noFill/>
         </p:spPr>
         <p:txBody>
-          <a:bodyPr wrap="square">
-            <a:spAutoFit/>
+          <a:bodyPr wrap="square" tIns="54864" bIns="54864">
+            <a:normAutofit/>
           </a:bodyPr>
           <a:lstStyle/>
-          <a:p>
-            <a:endParaRPr dirty="0"/>
-          </a:p>
+          <a:p/>
           <a:p>
             <a:pPr>
               <a:spcAft>
@@ -2642,7 +2575,7 @@
               </a:spcAft>
             </a:pPr>
             <a:r>
-              <a:rPr sz="1200" b="0" dirty="0">
+              <a:rPr sz="1200" b="0">
                 <a:solidFill>
                   <a:srgbClr val="2E8B57"/>
                 </a:solidFill>
@@ -2657,7 +2590,7 @@
               </a:spcAft>
             </a:pPr>
             <a:r>
-              <a:rPr sz="1200" b="0" dirty="0">
+              <a:rPr sz="1200" b="0">
                 <a:solidFill>
                   <a:srgbClr val="C88A00"/>
                 </a:solidFill>
@@ -2672,7 +2605,7 @@
               </a:spcAft>
             </a:pPr>
             <a:r>
-              <a:rPr sz="1200" b="0" dirty="0">
+              <a:rPr sz="1200" b="0">
                 <a:solidFill>
                   <a:srgbClr val="C88A00"/>
                 </a:solidFill>
@@ -2691,7 +2624,7 @@
 </file>
 
 <file path=ppt/slides/slide6.xml><?xml version="1.0" encoding="utf-8"?>
-<p:sld xmlns:a="http://schemas.openxmlformats.org/drawingml/2006/main" xmlns:r="http://schemas.openxmlformats.org/officeDocument/2006/relationships" xmlns:p="http://schemas.openxmlformats.org/presentationml/2006/main">
+<p:sld xmlns:a="http://schemas.openxmlformats.org/drawingml/2006/main" xmlns:p="http://schemas.openxmlformats.org/presentationml/2006/main" xmlns:r="http://schemas.openxmlformats.org/officeDocument/2006/relationships">
   <p:cSld>
     <p:spTree>
       <p:nvGrpSpPr>
@@ -2699,14 +2632,7 @@
         <p:cNvGrpSpPr/>
         <p:nvPr/>
       </p:nvGrpSpPr>
-      <p:grpSpPr>
-        <a:xfrm>
-          <a:off x="0" y="0"/>
-          <a:ext cx="0" cy="0"/>
-          <a:chOff x="0" y="0"/>
-          <a:chExt cx="0" cy="0"/>
-        </a:xfrm>
-      </p:grpSpPr>
+      <p:grpSpPr/>
       <p:sp>
         <p:nvSpPr>
           <p:cNvPr id="2" name="TextBox 1"/>
@@ -2715,7 +2641,7 @@
         </p:nvSpPr>
         <p:spPr>
           <a:xfrm>
-            <a:off x="411480" y="182880"/>
+            <a:off x="411480" y="201168"/>
             <a:ext cx="8321040" cy="274320"/>
           </a:xfrm>
           <a:prstGeom prst="rect">
@@ -2724,8 +2650,8 @@
           <a:noFill/>
         </p:spPr>
         <p:txBody>
-          <a:bodyPr wrap="square">
-            <a:spAutoFit/>
+          <a:bodyPr wrap="square" tIns="54864" bIns="54864">
+            <a:normAutofit/>
           </a:bodyPr>
           <a:lstStyle/>
           <a:p>
@@ -2748,7 +2674,7 @@
         </p:nvSpPr>
         <p:spPr>
           <a:xfrm>
-            <a:off x="411480" y="457200"/>
+            <a:off x="411480" y="493775"/>
             <a:ext cx="8321040" cy="548640"/>
           </a:xfrm>
           <a:prstGeom prst="rect">
@@ -2757,8 +2683,8 @@
           <a:noFill/>
         </p:spPr>
         <p:txBody>
-          <a:bodyPr wrap="square">
-            <a:spAutoFit/>
+          <a:bodyPr wrap="square" tIns="54864" bIns="54864">
+            <a:normAutofit/>
           </a:bodyPr>
           <a:lstStyle/>
           <a:p>
@@ -2768,7 +2694,7 @@
                   <a:srgbClr val="1F2D50"/>
                 </a:solidFill>
               </a:rPr>
-              <a:t>Response is extremely rare — 243 non-responders for every 1 responder</a:t>
+              <a:t>Response is rare: 243 non-responders per 1 responder</a:t>
             </a:r>
           </a:p>
         </p:txBody>
@@ -2781,7 +2707,7 @@
         </p:nvSpPr>
         <p:spPr>
           <a:xfrm>
-            <a:off x="411480" y="1024128"/>
+            <a:off x="411480" y="1133855"/>
             <a:ext cx="8321040" cy="18000"/>
           </a:xfrm>
           <a:prstGeom prst="rect">
@@ -2813,7 +2739,6 @@
           <a:lstStyle/>
           <a:p>
             <a:pPr algn="ctr"/>
-            <a:endParaRPr/>
           </a:p>
         </p:txBody>
       </p:sp>
@@ -2825,8 +2750,8 @@
         </p:nvSpPr>
         <p:spPr>
           <a:xfrm>
-            <a:off x="411480" y="1108641"/>
-            <a:ext cx="4572000" cy="3200400"/>
+            <a:off x="411480" y="1271015"/>
+            <a:ext cx="4480560" cy="3017520"/>
           </a:xfrm>
           <a:prstGeom prst="rect">
             <a:avLst/>
@@ -2834,13 +2759,11 @@
           <a:noFill/>
         </p:spPr>
         <p:txBody>
-          <a:bodyPr wrap="square">
-            <a:spAutoFit/>
+          <a:bodyPr wrap="square" tIns="54864" bIns="54864">
+            <a:normAutofit/>
           </a:bodyPr>
           <a:lstStyle/>
-          <a:p>
-            <a:endParaRPr/>
-          </a:p>
+          <a:p/>
           <a:p>
             <a:pPr>
               <a:spcAft>
@@ -2934,8 +2857,8 @@
         </p:blipFill>
         <p:spPr>
           <a:xfrm>
-            <a:off x="5074920" y="1252440"/>
-            <a:ext cx="3657600" cy="3228120"/>
+            <a:off x="5029200" y="1271015"/>
+            <a:ext cx="3794760" cy="3035808"/>
           </a:xfrm>
           <a:prstGeom prst="rect">
             <a:avLst/>
@@ -2950,8 +2873,8 @@
         </p:nvSpPr>
         <p:spPr>
           <a:xfrm>
-            <a:off x="411480" y="4526280"/>
-            <a:ext cx="8321040" cy="320040"/>
+            <a:off x="5029200" y="4443984"/>
+            <a:ext cx="3794760" cy="320040"/>
           </a:xfrm>
           <a:prstGeom prst="rect">
             <a:avLst/>
@@ -2959,8 +2882,8 @@
           <a:noFill/>
         </p:spPr>
         <p:txBody>
-          <a:bodyPr wrap="square">
-            <a:spAutoFit/>
+          <a:bodyPr wrap="square" tIns="54864" bIns="54864">
+            <a:normAutofit/>
           </a:bodyPr>
           <a:lstStyle/>
           <a:p>
@@ -2985,7 +2908,7 @@
 </file>
 
 <file path=ppt/slides/slide7.xml><?xml version="1.0" encoding="utf-8"?>
-<p:sld xmlns:a="http://schemas.openxmlformats.org/drawingml/2006/main" xmlns:r="http://schemas.openxmlformats.org/officeDocument/2006/relationships" xmlns:p="http://schemas.openxmlformats.org/presentationml/2006/main">
+<p:sld xmlns:a="http://schemas.openxmlformats.org/drawingml/2006/main" xmlns:p="http://schemas.openxmlformats.org/presentationml/2006/main" xmlns:r="http://schemas.openxmlformats.org/officeDocument/2006/relationships">
   <p:cSld>
     <p:spTree>
       <p:nvGrpSpPr>
@@ -2993,14 +2916,7 @@
         <p:cNvGrpSpPr/>
         <p:nvPr/>
       </p:nvGrpSpPr>
-      <p:grpSpPr>
-        <a:xfrm>
-          <a:off x="0" y="0"/>
-          <a:ext cx="0" cy="0"/>
-          <a:chOff x="0" y="0"/>
-          <a:chExt cx="0" cy="0"/>
-        </a:xfrm>
-      </p:grpSpPr>
+      <p:grpSpPr/>
       <p:sp>
         <p:nvSpPr>
           <p:cNvPr id="2" name="TextBox 1"/>
@@ -3009,7 +2925,7 @@
         </p:nvSpPr>
         <p:spPr>
           <a:xfrm>
-            <a:off x="411480" y="182880"/>
+            <a:off x="411480" y="201168"/>
             <a:ext cx="8321040" cy="274320"/>
           </a:xfrm>
           <a:prstGeom prst="rect">
@@ -3018,8 +2934,8 @@
           <a:noFill/>
         </p:spPr>
         <p:txBody>
-          <a:bodyPr wrap="square">
-            <a:spAutoFit/>
+          <a:bodyPr wrap="square" tIns="54864" bIns="54864">
+            <a:normAutofit/>
           </a:bodyPr>
           <a:lstStyle/>
           <a:p>
@@ -3042,7 +2958,7 @@
         </p:nvSpPr>
         <p:spPr>
           <a:xfrm>
-            <a:off x="411480" y="457200"/>
+            <a:off x="411480" y="493775"/>
             <a:ext cx="8321040" cy="548640"/>
           </a:xfrm>
           <a:prstGeom prst="rect">
@@ -3051,8 +2967,8 @@
           <a:noFill/>
         </p:spPr>
         <p:txBody>
-          <a:bodyPr wrap="square">
-            <a:spAutoFit/>
+          <a:bodyPr wrap="square" tIns="54864" bIns="54864">
+            <a:normAutofit/>
           </a:bodyPr>
           <a:lstStyle/>
           <a:p>
@@ -3062,7 +2978,7 @@
                   <a:srgbClr val="1F2D50"/>
                 </a:solidFill>
               </a:rPr>
-              <a:t>Responders carry more debt and are more actively shopping for credit</a:t>
+              <a:t>Responders carry more debt and shop more actively</a:t>
             </a:r>
           </a:p>
         </p:txBody>
@@ -3075,7 +2991,7 @@
         </p:nvSpPr>
         <p:spPr>
           <a:xfrm>
-            <a:off x="411480" y="1024128"/>
+            <a:off x="411480" y="1133855"/>
             <a:ext cx="8321040" cy="18000"/>
           </a:xfrm>
           <a:prstGeom prst="rect">
@@ -3107,7 +3023,6 @@
           <a:lstStyle/>
           <a:p>
             <a:pPr algn="ctr"/>
-            <a:endParaRPr/>
           </a:p>
         </p:txBody>
       </p:sp>
@@ -3127,8 +3042,8 @@
         </p:blipFill>
         <p:spPr>
           <a:xfrm>
-            <a:off x="274320" y="1078992"/>
-            <a:ext cx="5201920" cy="2926080"/>
+            <a:off x="2923539" y="1271015"/>
+            <a:ext cx="3251200" cy="1828800"/>
           </a:xfrm>
           <a:prstGeom prst="rect">
             <a:avLst/>
@@ -3143,7 +3058,7 @@
         </p:nvSpPr>
         <p:spPr>
           <a:xfrm>
-            <a:off x="411480" y="4050791"/>
+            <a:off x="411480" y="3236975"/>
             <a:ext cx="8321040" cy="320040"/>
           </a:xfrm>
           <a:prstGeom prst="rect">
@@ -3152,8 +3067,8 @@
           <a:noFill/>
         </p:spPr>
         <p:txBody>
-          <a:bodyPr wrap="square">
-            <a:spAutoFit/>
+          <a:bodyPr wrap="square" tIns="54864" bIns="54864">
+            <a:normAutofit/>
           </a:bodyPr>
           <a:lstStyle/>
           <a:p>
@@ -3177,7 +3092,7 @@
         </p:nvSpPr>
         <p:spPr>
           <a:xfrm>
-            <a:off x="411480" y="4187952"/>
+            <a:off x="411480" y="3694176"/>
             <a:ext cx="8321040" cy="960120"/>
           </a:xfrm>
           <a:prstGeom prst="rect">
@@ -3186,13 +3101,11 @@
           <a:noFill/>
         </p:spPr>
         <p:txBody>
-          <a:bodyPr wrap="square">
-            <a:spAutoFit/>
+          <a:bodyPr wrap="square" tIns="54864" bIns="54864">
+            <a:normAutofit/>
           </a:bodyPr>
           <a:lstStyle/>
-          <a:p>
-            <a:endParaRPr/>
-          </a:p>
+          <a:p/>
           <a:p>
             <a:pPr>
               <a:spcAft>
@@ -3249,7 +3162,7 @@
 </file>
 
 <file path=ppt/slides/slide8.xml><?xml version="1.0" encoding="utf-8"?>
-<p:sld xmlns:a="http://schemas.openxmlformats.org/drawingml/2006/main" xmlns:r="http://schemas.openxmlformats.org/officeDocument/2006/relationships" xmlns:p="http://schemas.openxmlformats.org/presentationml/2006/main">
+<p:sld xmlns:a="http://schemas.openxmlformats.org/drawingml/2006/main" xmlns:p="http://schemas.openxmlformats.org/presentationml/2006/main" xmlns:r="http://schemas.openxmlformats.org/officeDocument/2006/relationships">
   <p:cSld>
     <p:spTree>
       <p:nvGrpSpPr>
@@ -3257,14 +3170,7 @@
         <p:cNvGrpSpPr/>
         <p:nvPr/>
       </p:nvGrpSpPr>
-      <p:grpSpPr>
-        <a:xfrm>
-          <a:off x="0" y="0"/>
-          <a:ext cx="0" cy="0"/>
-          <a:chOff x="0" y="0"/>
-          <a:chExt cx="0" cy="0"/>
-        </a:xfrm>
-      </p:grpSpPr>
+      <p:grpSpPr/>
       <p:sp>
         <p:nvSpPr>
           <p:cNvPr id="2" name="TextBox 1"/>
@@ -3273,7 +3179,7 @@
         </p:nvSpPr>
         <p:spPr>
           <a:xfrm>
-            <a:off x="411480" y="182880"/>
+            <a:off x="411480" y="201168"/>
             <a:ext cx="8321040" cy="274320"/>
           </a:xfrm>
           <a:prstGeom prst="rect">
@@ -3282,8 +3188,8 @@
           <a:noFill/>
         </p:spPr>
         <p:txBody>
-          <a:bodyPr wrap="square">
-            <a:spAutoFit/>
+          <a:bodyPr wrap="square" tIns="54864" bIns="54864">
+            <a:normAutofit/>
           </a:bodyPr>
           <a:lstStyle/>
           <a:p>
@@ -3306,8 +3212,8 @@
         </p:nvSpPr>
         <p:spPr>
           <a:xfrm>
-            <a:off x="411480" y="457199"/>
-            <a:ext cx="8549640" cy="769441"/>
+            <a:off x="411480" y="493775"/>
+            <a:ext cx="8321040" cy="548640"/>
           </a:xfrm>
           <a:prstGeom prst="rect">
             <a:avLst/>
@@ -3315,18 +3221,18 @@
           <a:noFill/>
         </p:spPr>
         <p:txBody>
-          <a:bodyPr wrap="square">
-            <a:spAutoFit/>
+          <a:bodyPr wrap="square" tIns="54864" bIns="54864">
+            <a:normAutofit/>
           </a:bodyPr>
           <a:lstStyle/>
           <a:p>
             <a:r>
-              <a:rPr sz="2200" b="1" dirty="0">
+              <a:rPr sz="2200" b="1">
                 <a:solidFill>
                   <a:srgbClr val="1F2D50"/>
                 </a:solidFill>
               </a:rPr>
-              <a:t>Each metric family contributes unique information — there is no hidden redundancy beyond the bureau triplets</a:t>
+              <a:t>Each metric family adds unique, non-redundant signal</a:t>
             </a:r>
           </a:p>
         </p:txBody>
@@ -3339,7 +3245,7 @@
         </p:nvSpPr>
         <p:spPr>
           <a:xfrm>
-            <a:off x="411480" y="1024128"/>
+            <a:off x="411480" y="1133855"/>
             <a:ext cx="8321040" cy="18000"/>
           </a:xfrm>
           <a:prstGeom prst="rect">
@@ -3371,7 +3277,6 @@
           <a:lstStyle/>
           <a:p>
             <a:pPr algn="ctr"/>
-            <a:endParaRPr/>
           </a:p>
         </p:txBody>
       </p:sp>
@@ -3383,8 +3288,8 @@
         </p:nvSpPr>
         <p:spPr>
           <a:xfrm>
-            <a:off x="411480" y="1115568"/>
-            <a:ext cx="4389120" cy="3200400"/>
+            <a:off x="411480" y="1271015"/>
+            <a:ext cx="4206240" cy="3017520"/>
           </a:xfrm>
           <a:prstGeom prst="rect">
             <a:avLst/>
@@ -3392,13 +3297,11 @@
           <a:noFill/>
         </p:spPr>
         <p:txBody>
-          <a:bodyPr wrap="square">
-            <a:spAutoFit/>
+          <a:bodyPr wrap="square" tIns="54864" bIns="54864">
+            <a:normAutofit/>
           </a:bodyPr>
           <a:lstStyle/>
-          <a:p>
-            <a:endParaRPr/>
-          </a:p>
+          <a:p/>
           <a:p>
             <a:pPr>
               <a:spcAft>
@@ -3522,8 +3425,8 @@
         </p:blipFill>
         <p:spPr>
           <a:xfrm>
-            <a:off x="5029200" y="1205568"/>
-            <a:ext cx="4045527" cy="3274992"/>
+            <a:off x="4924044" y="1271015"/>
+            <a:ext cx="3730752" cy="3108960"/>
           </a:xfrm>
           <a:prstGeom prst="rect">
             <a:avLst/>
@@ -3538,8 +3441,8 @@
         </p:nvSpPr>
         <p:spPr>
           <a:xfrm>
-            <a:off x="411480" y="4526280"/>
-            <a:ext cx="8321040" cy="320040"/>
+            <a:off x="4754880" y="4517136"/>
+            <a:ext cx="4069080" cy="320040"/>
           </a:xfrm>
           <a:prstGeom prst="rect">
             <a:avLst/>
@@ -3547,8 +3450,8 @@
           <a:noFill/>
         </p:spPr>
         <p:txBody>
-          <a:bodyPr wrap="square">
-            <a:spAutoFit/>
+          <a:bodyPr wrap="square" tIns="54864" bIns="54864">
+            <a:normAutofit/>
           </a:bodyPr>
           <a:lstStyle/>
           <a:p>
@@ -3573,7 +3476,7 @@
 </file>
 
 <file path=ppt/slides/slide9.xml><?xml version="1.0" encoding="utf-8"?>
-<p:sld xmlns:a="http://schemas.openxmlformats.org/drawingml/2006/main" xmlns:r="http://schemas.openxmlformats.org/officeDocument/2006/relationships" xmlns:p="http://schemas.openxmlformats.org/presentationml/2006/main">
+<p:sld xmlns:a="http://schemas.openxmlformats.org/drawingml/2006/main" xmlns:p="http://schemas.openxmlformats.org/presentationml/2006/main" xmlns:r="http://schemas.openxmlformats.org/officeDocument/2006/relationships">
   <p:cSld>
     <p:spTree>
       <p:nvGrpSpPr>
@@ -3581,14 +3484,7 @@
         <p:cNvGrpSpPr/>
         <p:nvPr/>
       </p:nvGrpSpPr>
-      <p:grpSpPr>
-        <a:xfrm>
-          <a:off x="0" y="0"/>
-          <a:ext cx="0" cy="0"/>
-          <a:chOff x="0" y="0"/>
-          <a:chExt cx="0" cy="0"/>
-        </a:xfrm>
-      </p:grpSpPr>
+      <p:grpSpPr/>
       <p:sp>
         <p:nvSpPr>
           <p:cNvPr id="2" name="TextBox 1"/>
@@ -3597,7 +3493,7 @@
         </p:nvSpPr>
         <p:spPr>
           <a:xfrm>
-            <a:off x="411480" y="182880"/>
+            <a:off x="411480" y="201168"/>
             <a:ext cx="8321040" cy="274320"/>
           </a:xfrm>
           <a:prstGeom prst="rect">
@@ -3606,8 +3502,8 @@
           <a:noFill/>
         </p:spPr>
         <p:txBody>
-          <a:bodyPr wrap="square">
-            <a:spAutoFit/>
+          <a:bodyPr wrap="square" tIns="54864" bIns="54864">
+            <a:normAutofit/>
           </a:bodyPr>
           <a:lstStyle/>
           <a:p>
@@ -3630,7 +3526,7 @@
         </p:nvSpPr>
         <p:spPr>
           <a:xfrm>
-            <a:off x="411480" y="457200"/>
+            <a:off x="411480" y="493775"/>
             <a:ext cx="8321040" cy="548640"/>
           </a:xfrm>
           <a:prstGeom prst="rect">
@@ -3639,8 +3535,8 @@
           <a:noFill/>
         </p:spPr>
         <p:txBody>
-          <a:bodyPr wrap="square">
-            <a:spAutoFit/>
+          <a:bodyPr wrap="square" tIns="54864" bIns="54864">
+            <a:normAutofit/>
           </a:bodyPr>
           <a:lstStyle/>
           <a:p>
@@ -3650,7 +3546,7 @@
                   <a:srgbClr val="1F2D50"/>
                 </a:solidFill>
               </a:rPr>
-              <a:t>Response rates are stable across all three mailing waves — no seasonal or list-quality concerns</a:t>
+              <a:t>Response rates are stable across all three mailing waves</a:t>
             </a:r>
           </a:p>
         </p:txBody>
@@ -3663,7 +3559,7 @@
         </p:nvSpPr>
         <p:spPr>
           <a:xfrm>
-            <a:off x="411480" y="1024128"/>
+            <a:off x="411480" y="1133855"/>
             <a:ext cx="8321040" cy="18000"/>
           </a:xfrm>
           <a:prstGeom prst="rect">
@@ -3695,7 +3591,6 @@
           <a:lstStyle/>
           <a:p>
             <a:pPr algn="ctr"/>
-            <a:endParaRPr/>
           </a:p>
         </p:txBody>
       </p:sp>
@@ -3715,8 +3610,8 @@
         </p:blipFill>
         <p:spPr>
           <a:xfrm>
-            <a:off x="914400" y="1078992"/>
-            <a:ext cx="4828032" cy="3017520"/>
+            <a:off x="3186684" y="1271015"/>
+            <a:ext cx="3364991" cy="2103120"/>
           </a:xfrm>
           <a:prstGeom prst="rect">
             <a:avLst/>
@@ -3731,7 +3626,7 @@
         </p:nvSpPr>
         <p:spPr>
           <a:xfrm>
-            <a:off x="411480" y="4142232"/>
+            <a:off x="411480" y="3511295"/>
             <a:ext cx="8321040" cy="320040"/>
           </a:xfrm>
           <a:prstGeom prst="rect">
@@ -3740,8 +3635,8 @@
           <a:noFill/>
         </p:spPr>
         <p:txBody>
-          <a:bodyPr wrap="square">
-            <a:spAutoFit/>
+          <a:bodyPr wrap="square" tIns="54864" bIns="54864">
+            <a:normAutofit/>
           </a:bodyPr>
           <a:lstStyle/>
           <a:p>
@@ -3765,7 +3660,7 @@
         </p:nvSpPr>
         <p:spPr>
           <a:xfrm>
-            <a:off x="411480" y="4279392"/>
+            <a:off x="411480" y="3968496"/>
             <a:ext cx="8321040" cy="868680"/>
           </a:xfrm>
           <a:prstGeom prst="rect">
@@ -3774,13 +3669,11 @@
           <a:noFill/>
         </p:spPr>
         <p:txBody>
-          <a:bodyPr wrap="square">
-            <a:spAutoFit/>
+          <a:bodyPr wrap="square" tIns="54864" bIns="54864">
+            <a:normAutofit/>
           </a:bodyPr>
           <a:lstStyle/>
-          <a:p>
-            <a:endParaRPr/>
-          </a:p>
+          <a:p/>
           <a:p>
             <a:pPr>
               <a:spcAft>
@@ -4432,17 +4325,6 @@
 </file>
 
 <file path=customXml/item1.xml><?xml version="1.0" encoding="utf-8"?>
-<p:properties xmlns:p="http://schemas.microsoft.com/office/2006/metadata/properties" xmlns:xsi="http://www.w3.org/2001/XMLSchema-instance" xmlns:pc="http://schemas.microsoft.com/office/infopath/2007/PartnerControls">
-  <documentManagement>
-    <Functions xmlns="95b248c1-8001-4b31-82a9-b788a71d9657">
-      <Value>Others</Value>
-    </Functions>
-    <Skills xmlns="95b248c1-8001-4b31-82a9-b788a71d9657"/>
-  </documentManagement>
-</p:properties>
-</file>
-
-<file path=customXml/item2.xml><?xml version="1.0" encoding="utf-8"?>
 <ct:contentTypeSchema xmlns:ct="http://schemas.microsoft.com/office/2006/metadata/contentType" xmlns:ma="http://schemas.microsoft.com/office/2006/metadata/properties/metaAttributes" ct:_="" ma:_="" ma:contentTypeName="Document" ma:contentTypeID="0x010100A17475FABDB7754F9FF50381C508918F" ma:contentTypeVersion="10" ma:contentTypeDescription="Create a new document." ma:contentTypeScope="" ma:versionID="29148ed48be9ea64df027db204fc1c6e">
   <xsd:schema xmlns:xsd="http://www.w3.org/2001/XMLSchema" xmlns:xs="http://www.w3.org/2001/XMLSchema" xmlns:p="http://schemas.microsoft.com/office/2006/metadata/properties" xmlns:ns2="95b248c1-8001-4b31-82a9-b788a71d9657" targetNamespace="http://schemas.microsoft.com/office/2006/metadata/properties" ma:root="true" ma:fieldsID="a57b09182cebf370c1df8ff2537c6380" ns2:_="">
     <xsd:import namespace="95b248c1-8001-4b31-82a9-b788a71d9657"/>
@@ -4643,6 +4525,17 @@
 </ct:contentTypeSchema>
 </file>
 
+<file path=customXml/item2.xml><?xml version="1.0" encoding="utf-8"?>
+<p:properties xmlns:p="http://schemas.microsoft.com/office/2006/metadata/properties" xmlns:xsi="http://www.w3.org/2001/XMLSchema-instance" xmlns:pc="http://schemas.microsoft.com/office/infopath/2007/PartnerControls">
+  <documentManagement>
+    <Functions xmlns="95b248c1-8001-4b31-82a9-b788a71d9657">
+      <Value>Others</Value>
+    </Functions>
+    <Skills xmlns="95b248c1-8001-4b31-82a9-b788a71d9657"/>
+  </documentManagement>
+</p:properties>
+</file>
+
 <file path=customXml/item3.xml><?xml version="1.0" encoding="utf-8"?>
 <?mso-contentType ?>
 <FormTemplates xmlns="http://schemas.microsoft.com/sharepoint/v3/contenttype/forms">
@@ -4653,6 +4546,10 @@
 </file>
 
 <file path=customXml/itemProps1.xml><?xml version="1.0" encoding="utf-8"?>
+<ds:datastoreItem xmlns:ds="http://schemas.openxmlformats.org/officeDocument/2006/customXml" ds:itemID="{AF6D0A70-04C4-4860-ACC3-87918A8C21B2}"/>
+</file>
+
+<file path=customXml/itemProps2.xml><?xml version="1.0" encoding="utf-8"?>
 <ds:datastoreItem xmlns:ds="http://schemas.openxmlformats.org/officeDocument/2006/customXml" ds:itemID="{463C6CA0-EFE3-4D5F-89D3-100397768F24}">
   <ds:schemaRefs>
     <ds:schemaRef ds:uri="http://schemas.microsoft.com/office/2006/metadata/properties"/>
@@ -4665,25 +4562,6 @@
     <ds:schemaRef ds:uri="http://schemas.microsoft.com/office/infopath/2007/PartnerControls"/>
     <ds:schemaRef ds:uri="http://schemas.openxmlformats.org/package/2006/metadata/core-properties"/>
     <ds:schemaRef ds:uri="67853456-3ee1-4edc-9403-335e2be123a6"/>
-    <ds:schemaRef ds:uri="95b248c1-8001-4b31-82a9-b788a71d9657"/>
-  </ds:schemaRefs>
-</ds:datastoreItem>
-</file>
-
-<file path=customXml/itemProps2.xml><?xml version="1.0" encoding="utf-8"?>
-<ds:datastoreItem xmlns:ds="http://schemas.openxmlformats.org/officeDocument/2006/customXml" ds:itemID="{AF6D0A70-04C4-4860-ACC3-87918A8C21B2}">
-  <ds:schemaRefs>
-    <ds:schemaRef ds:uri="http://schemas.microsoft.com/office/2006/metadata/contentType"/>
-    <ds:schemaRef ds:uri="http://schemas.microsoft.com/office/2006/metadata/properties/metaAttributes"/>
-    <ds:schemaRef ds:uri="http://www.w3.org/2001/XMLSchema"/>
-    <ds:schemaRef ds:uri="http://schemas.microsoft.com/office/2006/metadata/properties"/>
-    <ds:schemaRef ds:uri="95b248c1-8001-4b31-82a9-b788a71d9657"/>
-    <ds:schemaRef ds:uri="http://schemas.microsoft.com/office/2006/documentManagement/types"/>
-    <ds:schemaRef ds:uri="http://schemas.microsoft.com/office/infopath/2007/PartnerControls"/>
-    <ds:schemaRef ds:uri="http://schemas.openxmlformats.org/package/2006/metadata/core-properties"/>
-    <ds:schemaRef ds:uri="http://purl.org/dc/elements/1.1/"/>
-    <ds:schemaRef ds:uri="http://purl.org/dc/terms/"/>
-    <ds:schemaRef ds:uri="http://schemas.microsoft.com/internal/obd"/>
   </ds:schemaRefs>
 </ds:datastoreItem>
 </file>

</xml_diff>